<commit_message>
System Design 101 (vi): sd-11-036 neutral timeline framing; sd-11-038 event-driven breaker simulation, claims split per pattern
Co-Authored-By: Claude Sonnet 5.5 <noreply@anthropic.com>
Claude-Session: https://claude.ai/code/session_01MF1cUkoXgxEMeDan8VPPYR
</commit_message>
<xml_diff>
--- a/system-design-101/vi/lessons/sd-11-036/slides/sd-11-036.pptx
+++ b/system-design-101/vi/lessons/sd-11-036/slides/sd-11-036.pptx
@@ -2045,7 +2045,7 @@
               <a:t> mốc</a:t>
             </a:r>
             <a:r>
-              <a:rPr lang="en-US" sz="2100" dirty="0" spc="-3" kern="0">
+              <a:rPr lang="en-US" sz="2100" dirty="0" spc="9" kern="0">
                 <a:solidFill>
                   <a:srgbClr val="9AA0B5"/>
                 </a:solidFill>
@@ -2053,7 +2053,7 @@
                 <a:ea typeface="Be Vietnam Pro" pitchFamily="34" charset="-122"/>
                 <a:cs typeface="Be Vietnam Pro" pitchFamily="34" charset="-120"/>
               </a:rPr>
-              <a:t> dời</a:t>
+              <a:t> đổi</a:t>
             </a:r>
             <a:r>
               <a:rPr lang="en-US" sz="2100" dirty="0" spc="4" kern="0">
@@ -2078,7 +2078,7 @@
               <a:t> ranh</a:t>
             </a:r>
             <a:r>
-              <a:rPr lang="en-US" sz="2100" dirty="0" spc="-1" kern="0">
+              <a:rPr lang="en-US" sz="2100" dirty="0" spc="0" kern="0">
                 <a:solidFill>
                   <a:srgbClr val="9AA0B5"/>
                 </a:solidFill>
@@ -4656,7 +4656,7 @@
               <a:t>Mỗi mốc</a:t>
             </a:r>
             <a:r>
-              <a:rPr lang="en-US" sz="9000" dirty="0" spc="-41" kern="0">
+              <a:rPr lang="en-US" sz="9000" dirty="0" spc="21" kern="0">
                 <a:solidFill>
                   <a:srgbClr val="14161C"/>
                 </a:solidFill>
@@ -4664,7 +4664,7 @@
                 <a:ea typeface="Bricolage Grotesque ExtraBold" pitchFamily="34" charset="-122"/>
                 <a:cs typeface="Bricolage Grotesque ExtraBold" pitchFamily="34" charset="-120"/>
               </a:rPr>
-              <a:t> dời</a:t>
+              <a:t> đổi</a:t>
             </a:r>
             <a:r>
               <a:rPr lang="en-US" sz="9000" dirty="0" spc="-83" kern="0">

</xml_diff>

<commit_message>
System Design 101 (vi): sd-11-037 figure and deck, sd-11-036 answer and deck match the corrected wording
Co-Authored-By: Claude Sonnet 5.5 <noreply@anthropic.com>
Claude-Session: https://claude.ai/code/session_01MF1cUkoXgxEMeDan8VPPYR
</commit_message>
<xml_diff>
--- a/system-design-101/vi/lessons/sd-11-036/slides/sd-11-036.pptx
+++ b/system-design-101/vi/lessons/sd-11-036/slides/sd-11-036.pptx
@@ -11167,7 +11167,7 @@
                 <a:ea typeface="Be Vietnam Pro" pitchFamily="34" charset="-122"/>
                 <a:cs typeface="Be Vietnam Pro" pitchFamily="34" charset="-120"/>
               </a:rPr>
-              <a:t> soát,</a:t>
+              <a:t> soát;</a:t>
             </a:r>
             <a:r>
               <a:rPr lang="en-US" sz="3150" b="1" dirty="0" spc="-11" kern="0">
@@ -11189,7 +11189,40 @@
                 <a:ea typeface="Be Vietnam Pro" pitchFamily="34" charset="-122"/>
                 <a:cs typeface="Be Vietnam Pro" pitchFamily="34" charset="-120"/>
               </a:rPr>
-              <a:t> giống</a:t>
+              <a:t> nhất</a:t>
+            </a:r>
+            <a:r>
+              <a:rPr lang="en-US" sz="3150" b="1" dirty="0" spc="2" kern="0">
+                <a:solidFill>
+                  <a:srgbClr val="F3EEE3"/>
+                </a:solidFill>
+                <a:latin typeface="Be Vietnam Pro" pitchFamily="34" charset="0"/>
+                <a:ea typeface="Be Vietnam Pro" pitchFamily="34" charset="-122"/>
+                <a:cs typeface="Be Vietnam Pro" pitchFamily="34" charset="-120"/>
+              </a:rPr>
+              <a:t> quán</a:t>
+            </a:r>
+            <a:r>
+              <a:rPr lang="en-US" sz="3150" b="1" dirty="0" spc="-18" kern="0">
+                <a:solidFill>
+                  <a:srgbClr val="F3EEE3"/>
+                </a:solidFill>
+                <a:latin typeface="Be Vietnam Pro" pitchFamily="34" charset="0"/>
+                <a:ea typeface="Be Vietnam Pro" pitchFamily="34" charset="-122"/>
+                <a:cs typeface="Be Vietnam Pro" pitchFamily="34" charset="-120"/>
+              </a:rPr>
+              <a:t> trên</a:t>
+            </a:r>
+            <a:r>
+              <a:rPr lang="en-US" sz="3150" b="1" dirty="0" spc="-13" kern="0">
+                <a:solidFill>
+                  <a:srgbClr val="F3EEE3"/>
+                </a:solidFill>
+                <a:latin typeface="Be Vietnam Pro" pitchFamily="34" charset="0"/>
+                <a:ea typeface="Be Vietnam Pro" pitchFamily="34" charset="-122"/>
+                <a:cs typeface="Be Vietnam Pro" pitchFamily="34" charset="-120"/>
+              </a:rPr>
+              <a:t> máy</a:t>
             </a:r>
             <a:r>
               <a:rPr lang="en-US" sz="3150" b="1" dirty="0" spc="0" kern="0">
@@ -11200,7 +11233,29 @@
                 <a:ea typeface="Be Vietnam Pro" pitchFamily="34" charset="-122"/>
                 <a:cs typeface="Be Vietnam Pro" pitchFamily="34" charset="-120"/>
               </a:rPr>
-              <a:t> nhau.</a:t>
+              <a:t> chủ</a:t>
+            </a:r>
+            <a:r>
+              <a:rPr lang="en-US" sz="3150" b="1" dirty="0" spc="8" kern="0">
+                <a:solidFill>
+                  <a:srgbClr val="F3EEE3"/>
+                </a:solidFill>
+                <a:latin typeface="Be Vietnam Pro" pitchFamily="34" charset="0"/>
+                <a:ea typeface="Be Vietnam Pro" pitchFamily="34" charset="-122"/>
+                <a:cs typeface="Be Vietnam Pro" pitchFamily="34" charset="-120"/>
+              </a:rPr>
+              <a:t> tương</a:t>
+            </a:r>
+            <a:r>
+              <a:rPr lang="en-US" sz="3150" b="1" dirty="0" spc="1" kern="0">
+                <a:solidFill>
+                  <a:srgbClr val="F3EEE3"/>
+                </a:solidFill>
+                <a:latin typeface="Be Vietnam Pro" pitchFamily="34" charset="0"/>
+                <a:ea typeface="Be Vietnam Pro" pitchFamily="34" charset="-122"/>
+                <a:cs typeface="Be Vietnam Pro" pitchFamily="34" charset="-120"/>
+              </a:rPr>
+              <a:t> thích.</a:t>
             </a:r>
             <a:endParaRPr lang="en-US" sz="3150" dirty="0"/>
           </a:p>

</xml_diff>